<commit_message>
Absolute 40 bar; PIT decile test of v1 vs v3 at quarterly/1Y/3Y horizons
</commit_message>
<xml_diff>
--- a/Shreyas_Ionic_AMC/09_PRODUCT/reports/IONIC_NDPMS_PRODUCT_APPROVAL_DECK.pptx
+++ b/Shreyas_Ionic_AMC/09_PRODUCT/reports/IONIC_NDPMS_PRODUCT_APPROVAL_DECK.pptx
@@ -22122,7 +22122,7 @@
       </p:sp>
       <p:pic>
         <p:nvPicPr>
-          <p:cNvPr id="16" name="Picture 15" descr="snap_02_p004.png"/>
+          <p:cNvPr id="16" name="Picture 15" descr="snap_02_p005.png"/>
           <p:cNvPicPr>
             <a:picLocks noChangeAspect="1"/>
           </p:cNvPicPr>
@@ -22181,7 +22181,7 @@
                 </a:solidFill>
                 <a:latin typeface="Bahnschrift"/>
               </a:rPr>
-              <a:t>PAGE 4</a:t>
+              <a:t>PAGE 5</a:t>
             </a:r>
           </a:p>
         </p:txBody>
@@ -22279,7 +22279,7 @@
       </p:sp>
       <p:pic>
         <p:nvPicPr>
-          <p:cNvPr id="20" name="Picture 19" descr="snap_03_p007.png"/>
+          <p:cNvPr id="20" name="Picture 19" descr="snap_03_p008.png"/>
           <p:cNvPicPr>
             <a:picLocks noChangeAspect="1"/>
           </p:cNvPicPr>
@@ -22338,7 +22338,7 @@
                 </a:solidFill>
                 <a:latin typeface="Bahnschrift"/>
               </a:rPr>
-              <a:t>PAGE 7</a:t>
+              <a:t>PAGE 8</a:t>
             </a:r>
           </a:p>
         </p:txBody>
@@ -23038,7 +23038,7 @@
       </p:sp>
       <p:pic>
         <p:nvPicPr>
-          <p:cNvPr id="16" name="Picture 15" descr="snap_04_p009.png"/>
+          <p:cNvPr id="16" name="Picture 15" descr="snap_04_p010.png"/>
           <p:cNvPicPr>
             <a:picLocks noChangeAspect="1"/>
           </p:cNvPicPr>
@@ -23097,7 +23097,7 @@
                 </a:solidFill>
                 <a:latin typeface="Bahnschrift"/>
               </a:rPr>
-              <a:t>PAGE 9</a:t>
+              <a:t>PAGE 10</a:t>
             </a:r>
           </a:p>
         </p:txBody>
@@ -23195,7 +23195,7 @@
       </p:sp>
       <p:pic>
         <p:nvPicPr>
-          <p:cNvPr id="20" name="Picture 19" descr="snap_05_p010.png"/>
+          <p:cNvPr id="20" name="Picture 19" descr="snap_05_p011.png"/>
           <p:cNvPicPr>
             <a:picLocks noChangeAspect="1"/>
           </p:cNvPicPr>
@@ -23254,7 +23254,7 @@
                 </a:solidFill>
                 <a:latin typeface="Bahnschrift"/>
               </a:rPr>
-              <a:t>PAGE 10</a:t>
+              <a:t>PAGE 11</a:t>
             </a:r>
           </a:p>
         </p:txBody>
@@ -23954,7 +23954,7 @@
       </p:sp>
       <p:pic>
         <p:nvPicPr>
-          <p:cNvPr id="16" name="Picture 15" descr="snap_06_p013.png"/>
+          <p:cNvPr id="16" name="Picture 15" descr="snap_06_p023.png"/>
           <p:cNvPicPr>
             <a:picLocks noChangeAspect="1"/>
           </p:cNvPicPr>
@@ -24013,7 +24013,7 @@
                 </a:solidFill>
                 <a:latin typeface="Bahnschrift"/>
               </a:rPr>
-              <a:t>PAGE 13</a:t>
+              <a:t>PAGE 23</a:t>
             </a:r>
           </a:p>
         </p:txBody>
@@ -24111,7 +24111,7 @@
       </p:sp>
       <p:pic>
         <p:nvPicPr>
-          <p:cNvPr id="20" name="Picture 19" descr="snap_07_p014.png"/>
+          <p:cNvPr id="20" name="Picture 19" descr="snap_07_p024.png"/>
           <p:cNvPicPr>
             <a:picLocks noChangeAspect="1"/>
           </p:cNvPicPr>
@@ -24170,7 +24170,7 @@
                 </a:solidFill>
                 <a:latin typeface="Bahnschrift"/>
               </a:rPr>
-              <a:t>PAGE 14</a:t>
+              <a:t>PAGE 24</a:t>
             </a:r>
           </a:p>
         </p:txBody>
@@ -24870,7 +24870,7 @@
       </p:sp>
       <p:pic>
         <p:nvPicPr>
-          <p:cNvPr id="16" name="Picture 15" descr="snap_08_p016.png"/>
+          <p:cNvPr id="16" name="Picture 15" descr="snap_08_p026.png"/>
           <p:cNvPicPr>
             <a:picLocks noChangeAspect="1"/>
           </p:cNvPicPr>
@@ -24929,7 +24929,7 @@
                 </a:solidFill>
                 <a:latin typeface="Bahnschrift"/>
               </a:rPr>
-              <a:t>PAGE 16</a:t>
+              <a:t>PAGE 26</a:t>
             </a:r>
           </a:p>
         </p:txBody>
@@ -25027,7 +25027,7 @@
       </p:sp>
       <p:pic>
         <p:nvPicPr>
-          <p:cNvPr id="20" name="Picture 19" descr="snap_09_p020.png"/>
+          <p:cNvPr id="20" name="Picture 19" descr="snap_09_p015.png"/>
           <p:cNvPicPr>
             <a:picLocks noChangeAspect="1"/>
           </p:cNvPicPr>
@@ -25086,7 +25086,7 @@
                 </a:solidFill>
                 <a:latin typeface="Bahnschrift"/>
               </a:rPr>
-              <a:t>PAGE 20</a:t>
+              <a:t>PAGE 15</a:t>
             </a:r>
           </a:p>
         </p:txBody>
@@ -25786,7 +25786,7 @@
       </p:sp>
       <p:pic>
         <p:nvPicPr>
-          <p:cNvPr id="16" name="Picture 15" descr="snap_10_p027.png"/>
+          <p:cNvPr id="16" name="Picture 15" descr="snap_10_p031.png"/>
           <p:cNvPicPr>
             <a:picLocks noChangeAspect="1"/>
           </p:cNvPicPr>
@@ -25845,7 +25845,7 @@
                 </a:solidFill>
                 <a:latin typeface="Bahnschrift"/>
               </a:rPr>
-              <a:t>PAGE 27</a:t>
+              <a:t>PAGE 31</a:t>
             </a:r>
           </a:p>
         </p:txBody>
@@ -25943,7 +25943,7 @@
       </p:sp>
       <p:pic>
         <p:nvPicPr>
-          <p:cNvPr id="20" name="Picture 19" descr="snap_11_p028.png"/>
+          <p:cNvPr id="20" name="Picture 19" descr="snap_11_p032.png"/>
           <p:cNvPicPr>
             <a:picLocks noChangeAspect="1"/>
           </p:cNvPicPr>
@@ -26002,7 +26002,7 @@
                 </a:solidFill>
                 <a:latin typeface="Bahnschrift"/>
               </a:rPr>
-              <a:t>PAGE 28</a:t>
+              <a:t>PAGE 32</a:t>
             </a:r>
           </a:p>
         </p:txBody>
@@ -26702,7 +26702,7 @@
       </p:sp>
       <p:pic>
         <p:nvPicPr>
-          <p:cNvPr id="16" name="Picture 15" descr="snap_12_p039.png"/>
+          <p:cNvPr id="16" name="Picture 15" descr="snap_12_p043.png"/>
           <p:cNvPicPr>
             <a:picLocks noChangeAspect="1"/>
           </p:cNvPicPr>
@@ -26761,7 +26761,7 @@
                 </a:solidFill>
                 <a:latin typeface="Bahnschrift"/>
               </a:rPr>
-              <a:t>PAGE 39</a:t>
+              <a:t>PAGE 43</a:t>
             </a:r>
           </a:p>
         </p:txBody>
@@ -26859,7 +26859,7 @@
       </p:sp>
       <p:pic>
         <p:nvPicPr>
-          <p:cNvPr id="20" name="Picture 19" descr="snap_13_p049.png"/>
+          <p:cNvPr id="20" name="Picture 19" descr="snap_13_p053.png"/>
           <p:cNvPicPr>
             <a:picLocks noChangeAspect="1"/>
           </p:cNvPicPr>
@@ -26918,7 +26918,7 @@
                 </a:solidFill>
                 <a:latin typeface="Bahnschrift"/>
               </a:rPr>
-              <a:t>PAGE 49</a:t>
+              <a:t>PAGE 53</a:t>
             </a:r>
           </a:p>
         </p:txBody>

</xml_diff>